<commit_message>
Training: Day 1 pack v2 filed (frozen build SSORT 153, Module 2 corrected); agendas say 153; reply appended
Co-Authored-By: Claude Fable 5.1 <noreply@anthropic.com>
Claude-Session: https://claude.ai/code/session_01HKpkuLyV6bHMBgkcjiDHio
</commit_message>
<xml_diff>
--- a/tools/received/training/day1/06-Day-1-Deck.pptx
+++ b/tools/received/training/day1/06-Day-1-Deck.pptx
@@ -39380,7 +39380,7 @@
                   <a:srgbClr val="002C77"/>
                 </a:solidFill>
               </a:rPr>
-              <a:t>SSORT  REV 152</a:t>
+              <a:t>SSORT  REV 153</a:t>
             </a:r>
           </a:p>
           <a:p>
@@ -39391,7 +39391,7 @@
             </a:pPr>
             <a:r>
               <a:rPr sz="1400" b="0"/>
-              <a:t>Test records attached to any CBM equipment; Riser Adapter graded and photographed; Post to OEM now posts to the dashboard as well.</a:t>
+              <a:t>Test records attached to any CBM equipment and sent on to NOV; Riser Adapter graded and photographed; Post to OEM now posts to the dashboard as well.</a:t>
             </a:r>
           </a:p>
           <a:p>

</xml_diff>

<commit_message>
Training: Day 1 pack v3 filed (Lee's opening slide, 08:30, 19 screenshots captured in the tools session's transcript); reply appended
Co-Authored-By: Claude Fable 5.1 <noreply@anthropic.com>
Claude-Session: https://claude.ai/code/session_01HKpkuLyV6bHMBgkcjiDHio
</commit_message>
<xml_diff>
--- a/tools/received/training/day1/06-Day-1-Deck.pptx
+++ b/tools/received/training/day1/06-Day-1-Deck.pptx
@@ -13,6 +13,7 @@
     <p:sldId id="257" r:id="rId14"/>
     <p:sldId id="258" r:id="rId15"/>
     <p:sldId id="259" r:id="rId16"/>
+    <p:sldId id="275" r:id="rId65"/>
     <p:sldId id="260" r:id="rId17"/>
     <p:sldId id="261" r:id="rId18"/>
     <p:sldId id="262" r:id="rId19"/>
@@ -35753,6 +35754,247 @@
       <p:grpSpPr/>
       <p:sp>
         <p:nvSpPr>
+          <p:cNvPr id="3" name="Title 2"/>
+          <p:cNvSpPr>
+            <a:spLocks noGrp="1"/>
+          </p:cNvSpPr>
+          <p:nvPr>
+            <p:ph type="title"/>
+          </p:nvPr>
+        </p:nvSpPr>
+        <p:spPr>
+          <a:xfrm>
+            <a:ext cx="11411760" cy="0"/>
+          </a:xfrm>
+        </p:spPr>
+        <p:txBody>
+          <a:bodyPr/>
+          <a:lstStyle/>
+          <a:p>
+            <a:r>
+              <a:rPr sz="3000" b="1"/>
+              <a:t>Five surface tests, all native now</a:t>
+            </a:r>
+          </a:p>
+        </p:txBody>
+      </p:sp>
+      <p:sp>
+        <p:nvSpPr>
+          <p:cNvPr id="4" name="Text Placeholder 3"/>
+          <p:cNvSpPr>
+            <a:spLocks noGrp="1"/>
+          </p:cNvSpPr>
+          <p:nvPr>
+            <p:ph type="body" idx="13" sz="quarter"/>
+          </p:nvPr>
+        </p:nvSpPr>
+        <p:spPr>
+          <a:xfrm>
+            <a:ext cx="11411760" cy="0"/>
+          </a:xfrm>
+        </p:spPr>
+        <p:txBody>
+          <a:bodyPr/>
+          <a:lstStyle/>
+          <a:p>
+            <a:r>
+              <a:rPr sz="1300" b="1">
+                <a:solidFill>
+                  <a:srgbClr val="5A6472"/>
+                </a:solidFill>
+              </a:rPr>
+              <a:t>REV 165 and 166 — the embedded tools are gone</a:t>
+            </a:r>
+          </a:p>
+        </p:txBody>
+      </p:sp>
+      <p:sp>
+        <p:nvSpPr>
+          <p:cNvPr id="5" name="Text Placeholder 4"/>
+          <p:cNvSpPr>
+            <a:spLocks noGrp="1"/>
+          </p:cNvSpPr>
+          <p:nvPr>
+            <p:ph type="body" idx="14" sz="quarter"/>
+          </p:nvPr>
+        </p:nvSpPr>
+        <p:spPr>
+          <a:xfrm>
+            <a:ext cx="11411760" cy="0"/>
+          </a:xfrm>
+        </p:spPr>
+        <p:txBody>
+          <a:bodyPr wrap="square"/>
+          <a:lstStyle/>
+          <a:p>
+            <a:pPr>
+              <a:spcAft>
+                <a:spcPts val="600"/>
+              </a:spcAft>
+            </a:pPr>
+            <a:r>
+              <a:rPr sz="1400" b="1"/>
+              <a:t>BOP Function Test</a:t>
+            </a:r>
+          </a:p>
+          <a:p>
+            <a:pPr>
+              <a:spcAft>
+                <a:spcPts val="600"/>
+              </a:spcAft>
+            </a:pPr>
+            <a:r>
+              <a:rPr sz="1400" b="0"/>
+              <a:t>ILF rows, pod pressures, regulator checks.</a:t>
+            </a:r>
+          </a:p>
+          <a:p>
+            <a:pPr>
+              <a:spcAft>
+                <a:spcPts val="600"/>
+              </a:spcAft>
+            </a:pPr>
+            <a:r>
+              <a:rPr sz="1400" b="1"/>
+              <a:t>EDS Verification</a:t>
+            </a:r>
+          </a:p>
+          <a:p>
+            <a:pPr>
+              <a:spcAft>
+                <a:spcPts val="600"/>
+              </a:spcAft>
+            </a:pPr>
+            <a:r>
+              <a:rPr sz="1400" b="0"/>
+              <a:t>Your rig's own sequences, step by step, with actual times and remarks.</a:t>
+            </a:r>
+          </a:p>
+          <a:p>
+            <a:pPr>
+              <a:spcAft>
+                <a:spcPts val="600"/>
+              </a:spcAft>
+            </a:pPr>
+            <a:r>
+              <a:rPr sz="1400" b="1"/>
+              <a:t>Acoustic Function Test</a:t>
+            </a:r>
+          </a:p>
+          <a:p>
+            <a:pPr>
+              <a:spcAft>
+                <a:spcPts val="600"/>
+              </a:spcAft>
+            </a:pPr>
+            <a:r>
+              <a:rPr sz="1400" b="0"/>
+              <a:t>Rig-specific. Three rigs have no acoustic system and will say so.</a:t>
+            </a:r>
+          </a:p>
+          <a:p>
+            <a:pPr>
+              <a:spcAft>
+                <a:spcPts val="600"/>
+              </a:spcAft>
+            </a:pPr>
+            <a:r>
+              <a:rPr sz="1400" b="1"/>
+              <a:t>EHBS</a:t>
+            </a:r>
+          </a:p>
+          <a:p>
+            <a:pPr>
+              <a:spcAft>
+                <a:spcPts val="600"/>
+              </a:spcAft>
+            </a:pPr>
+            <a:r>
+              <a:rPr sz="1400" b="0"/>
+              <a:t>Three rig classes. DMAS gets a two-part test.</a:t>
+            </a:r>
+          </a:p>
+          <a:p>
+            <a:pPr>
+              <a:spcAft>
+                <a:spcPts val="600"/>
+              </a:spcAft>
+            </a:pPr>
+            <a:r>
+              <a:rPr sz="1400" b="1"/>
+              <a:t>Surface Drawdown</a:t>
+            </a:r>
+          </a:p>
+          <a:p>
+            <a:pPr>
+              <a:spcAft>
+                <a:spcPts val="600"/>
+              </a:spcAft>
+            </a:pPr>
+            <a:r>
+              <a:rPr sz="1400" b="0"/>
+              <a:t>Derived PASS/FAIL — see the next point.</a:t>
+            </a:r>
+          </a:p>
+          <a:p>
+            <a:pPr>
+              <a:spcAft>
+                <a:spcPts val="600"/>
+              </a:spcAft>
+            </a:pPr>
+            <a:r>
+              <a:rPr sz="1400" b="0"/>
+              <a:t/>
+            </a:r>
+          </a:p>
+          <a:p>
+            <a:pPr>
+              <a:spcAft>
+                <a:spcPts val="600"/>
+              </a:spcAft>
+            </a:pPr>
+            <a:r>
+              <a:rPr sz="1400" b="1">
+                <a:solidFill>
+                  <a:srgbClr val="E25303"/>
+                </a:solidFill>
+              </a:rPr>
+              <a:t>Until REV 165 these were embedded tools and nothing you typed was saved.</a:t>
+            </a:r>
+          </a:p>
+          <a:p>
+            <a:pPr>
+              <a:spcAft>
+                <a:spcPts val="600"/>
+              </a:spcAft>
+            </a:pPr>
+            <a:r>
+              <a:rPr sz="1400" b="0"/>
+              <a:t>It printed and it looked right. It never reached the report. That is fixed; it is also why this module exists.</a:t>
+            </a:r>
+          </a:p>
+        </p:txBody>
+      </p:sp>
+    </p:spTree>
+  </p:cSld>
+  <p:clrMapOvr>
+    <a:masterClrMapping/>
+  </p:clrMapOvr>
+</p:sld>
+</file>
+
+<file path=ppt/slides/slide11.xml><?xml version="1.0" encoding="utf-8"?>
+<p:sld xmlns:a="http://schemas.openxmlformats.org/drawingml/2006/main" xmlns:p="http://schemas.openxmlformats.org/presentationml/2006/main" xmlns:r="http://schemas.openxmlformats.org/officeDocument/2006/relationships">
+  <p:cSld>
+    <p:spTree>
+      <p:nvGrpSpPr>
+        <p:cNvPr id="1" name=""/>
+        <p:cNvGrpSpPr/>
+        <p:nvPr/>
+      </p:nvGrpSpPr>
+      <p:grpSpPr/>
+      <p:sp>
+        <p:nvSpPr>
           <p:cNvPr id="2" name="Text Placeholder 1"/>
           <p:cNvSpPr>
             <a:spLocks noGrp="1"/>
@@ -36028,7 +36270,7 @@
 </p:sld>
 </file>
 
-<file path=ppt/slides/slide11.xml><?xml version="1.0" encoding="utf-8"?>
+<file path=ppt/slides/slide12.xml><?xml version="1.0" encoding="utf-8"?>
 <p:sld xmlns:a="http://schemas.openxmlformats.org/drawingml/2006/main" xmlns:p="http://schemas.openxmlformats.org/presentationml/2006/main" xmlns:r="http://schemas.openxmlformats.org/officeDocument/2006/relationships">
   <p:cSld>
     <p:spTree>
@@ -36097,7 +36339,7 @@
 </p:sld>
 </file>
 
-<file path=ppt/slides/slide12.xml><?xml version="1.0" encoding="utf-8"?>
+<file path=ppt/slides/slide13.xml><?xml version="1.0" encoding="utf-8"?>
 <p:sld xmlns:a="http://schemas.openxmlformats.org/drawingml/2006/main" xmlns:p="http://schemas.openxmlformats.org/presentationml/2006/main" xmlns:r="http://schemas.openxmlformats.org/officeDocument/2006/relationships">
   <p:cSld>
     <p:spTree>
@@ -36606,7 +36848,7 @@
 </p:sld>
 </file>
 
-<file path=ppt/slides/slide13.xml><?xml version="1.0" encoding="utf-8"?>
+<file path=ppt/slides/slide14.xml><?xml version="1.0" encoding="utf-8"?>
 <p:sld xmlns:a="http://schemas.openxmlformats.org/drawingml/2006/main" xmlns:p="http://schemas.openxmlformats.org/presentationml/2006/main" xmlns:r="http://schemas.openxmlformats.org/officeDocument/2006/relationships">
   <p:cSld>
     <p:spTree>
@@ -36897,7 +37139,7 @@
 </p:sld>
 </file>
 
-<file path=ppt/slides/slide14.xml><?xml version="1.0" encoding="utf-8"?>
+<file path=ppt/slides/slide15.xml><?xml version="1.0" encoding="utf-8"?>
 <p:sld xmlns:a="http://schemas.openxmlformats.org/drawingml/2006/main" xmlns:p="http://schemas.openxmlformats.org/presentationml/2006/main" xmlns:r="http://schemas.openxmlformats.org/officeDocument/2006/relationships">
   <p:cSld>
     <p:spTree>
@@ -37113,7 +37355,7 @@
 </p:sld>
 </file>
 
-<file path=ppt/slides/slide15.xml><?xml version="1.0" encoding="utf-8"?>
+<file path=ppt/slides/slide16.xml><?xml version="1.0" encoding="utf-8"?>
 <p:sld xmlns:a="http://schemas.openxmlformats.org/drawingml/2006/main" xmlns:p="http://schemas.openxmlformats.org/presentationml/2006/main" xmlns:r="http://schemas.openxmlformats.org/officeDocument/2006/relationships">
   <p:cSld>
     <p:spTree>
@@ -37182,7 +37424,7 @@
 </p:sld>
 </file>
 
-<file path=ppt/slides/slide16.xml><?xml version="1.0" encoding="utf-8"?>
+<file path=ppt/slides/slide17.xml><?xml version="1.0" encoding="utf-8"?>
 <p:sld xmlns:a="http://schemas.openxmlformats.org/drawingml/2006/main" xmlns:p="http://schemas.openxmlformats.org/presentationml/2006/main" xmlns:r="http://schemas.openxmlformats.org/officeDocument/2006/relationships">
   <p:cSld>
     <p:spTree>
@@ -37528,7 +37770,7 @@
 </p:sld>
 </file>
 
-<file path=ppt/slides/slide17.xml><?xml version="1.0" encoding="utf-8"?>
+<file path=ppt/slides/slide18.xml><?xml version="1.0" encoding="utf-8"?>
 <p:sld xmlns:a="http://schemas.openxmlformats.org/drawingml/2006/main" xmlns:p="http://schemas.openxmlformats.org/presentationml/2006/main" xmlns:r="http://schemas.openxmlformats.org/officeDocument/2006/relationships">
   <p:cSld>
     <p:spTree>
@@ -38536,7 +38778,7 @@
 </p:sld>
 </file>
 
-<file path=ppt/slides/slide18.xml><?xml version="1.0" encoding="utf-8"?>
+<file path=ppt/slides/slide19.xml><?xml version="1.0" encoding="utf-8"?>
 <p:sld xmlns:a="http://schemas.openxmlformats.org/drawingml/2006/main" xmlns:p="http://schemas.openxmlformats.org/presentationml/2006/main" xmlns:r="http://schemas.openxmlformats.org/officeDocument/2006/relationships">
   <p:cSld>
     <p:spTree>
@@ -38892,51 +39134,6 @@
             <a:r>
               <a:rPr sz="2800" b="1"/>
               <a:t>When Post fails — what you see, what you do</a:t>
-            </a:r>
-          </a:p>
-        </p:txBody>
-      </p:sp>
-    </p:spTree>
-  </p:cSld>
-  <p:clrMapOvr>
-    <a:masterClrMapping/>
-  </p:clrMapOvr>
-</p:sld>
-</file>
-
-<file path=ppt/slides/slide19.xml><?xml version="1.0" encoding="utf-8"?>
-<p:sld xmlns:a="http://schemas.openxmlformats.org/drawingml/2006/main" xmlns:p="http://schemas.openxmlformats.org/presentationml/2006/main" xmlns:r="http://schemas.openxmlformats.org/officeDocument/2006/relationships">
-  <p:cSld>
-    <p:spTree>
-      <p:nvGrpSpPr>
-        <p:cNvPr id="1" name=""/>
-        <p:cNvGrpSpPr/>
-        <p:nvPr/>
-      </p:nvGrpSpPr>
-      <p:grpSpPr/>
-      <p:sp>
-        <p:nvSpPr>
-          <p:cNvPr id="2" name="Text Placeholder 1"/>
-          <p:cNvSpPr>
-            <a:spLocks noGrp="1"/>
-          </p:cNvSpPr>
-          <p:nvPr>
-            <p:ph type="body" idx="12" sz="quarter"/>
-          </p:nvPr>
-        </p:nvSpPr>
-        <p:spPr/>
-        <p:txBody>
-          <a:bodyPr/>
-          <a:lstStyle/>
-          <a:p>
-            <a:r>
-              <a:rPr sz="2200" b="1">
-                <a:solidFill>
-                  <a:srgbClr val="FFFFFF"/>
-                </a:solidFill>
-              </a:rPr>
-              <a:t>The report is the evidence that the BOP was fit to run.
-Everything else is housekeeping.</a:t>
             </a:r>
           </a:p>
         </p:txBody>
@@ -39235,6 +39432,51 @@
             <a:r>
               <a:rPr sz="2800" b="1"/>
               <a:t>Three words that do not mean the same thing</a:t>
+            </a:r>
+          </a:p>
+        </p:txBody>
+      </p:sp>
+    </p:spTree>
+  </p:cSld>
+  <p:clrMapOvr>
+    <a:masterClrMapping/>
+  </p:clrMapOvr>
+</p:sld>
+</file>
+
+<file path=ppt/slides/slide20.xml><?xml version="1.0" encoding="utf-8"?>
+<p:sld xmlns:a="http://schemas.openxmlformats.org/drawingml/2006/main" xmlns:p="http://schemas.openxmlformats.org/presentationml/2006/main" xmlns:r="http://schemas.openxmlformats.org/officeDocument/2006/relationships">
+  <p:cSld>
+    <p:spTree>
+      <p:nvGrpSpPr>
+        <p:cNvPr id="1" name=""/>
+        <p:cNvGrpSpPr/>
+        <p:nvPr/>
+      </p:nvGrpSpPr>
+      <p:grpSpPr/>
+      <p:sp>
+        <p:nvSpPr>
+          <p:cNvPr id="2" name="Text Placeholder 1"/>
+          <p:cNvSpPr>
+            <a:spLocks noGrp="1"/>
+          </p:cNvSpPr>
+          <p:nvPr>
+            <p:ph type="body" idx="12" sz="quarter"/>
+          </p:nvPr>
+        </p:nvSpPr>
+        <p:spPr/>
+        <p:txBody>
+          <a:bodyPr/>
+          <a:lstStyle/>
+          <a:p>
+            <a:r>
+              <a:rPr sz="2200" b="1">
+                <a:solidFill>
+                  <a:srgbClr val="FFFFFF"/>
+                </a:solidFill>
+              </a:rPr>
+              <a:t>The report is the evidence that the BOP was fit to run.
+Everything else is housekeeping.</a:t>
             </a:r>
           </a:p>
         </p:txBody>
@@ -39494,7 +39736,7 @@
           <a:p>
             <a:r>
               <a:rPr sz="3000" b="1"/>
-              <a:t>Module 1</a:t>
+              <a:t>Opening</a:t>
             </a:r>
           </a:p>
         </p:txBody>
@@ -39519,7 +39761,7 @@
           <a:lstStyle/>
           <a:p>
             <a:r>
-              <a:t>WCGRRT: rig visit and daily reports   ·   08:00–10:00</a:t>
+              <a:t>Lee Arnold   ·   safety minute, roles and responsibilities, expectations for the week   ·   08:00–08:30</a:t>
             </a:r>
           </a:p>
         </p:txBody>
@@ -39533,6 +39775,75 @@
 </file>
 
 <file path=ppt/slides/slide5.xml><?xml version="1.0" encoding="utf-8"?>
+<p:sld xmlns:a="http://schemas.openxmlformats.org/drawingml/2006/main" xmlns:p="http://schemas.openxmlformats.org/presentationml/2006/main" xmlns:r="http://schemas.openxmlformats.org/officeDocument/2006/relationships">
+  <p:cSld>
+    <p:spTree>
+      <p:nvGrpSpPr>
+        <p:cNvPr id="1" name=""/>
+        <p:cNvGrpSpPr/>
+        <p:nvPr/>
+      </p:nvGrpSpPr>
+      <p:grpSpPr/>
+      <p:sp>
+        <p:nvSpPr>
+          <p:cNvPr id="3" name="Text Placeholder 2"/>
+          <p:cNvSpPr>
+            <a:spLocks noGrp="1"/>
+          </p:cNvSpPr>
+          <p:nvPr>
+            <p:ph type="body" idx="12" sz="quarter"/>
+          </p:nvPr>
+        </p:nvSpPr>
+        <p:spPr>
+          <a:xfrm>
+            <a:ext cx="11438875" cy="0"/>
+          </a:xfrm>
+        </p:spPr>
+        <p:txBody>
+          <a:bodyPr/>
+          <a:lstStyle/>
+          <a:p>
+            <a:r>
+              <a:rPr sz="3000" b="1"/>
+              <a:t>Module 1</a:t>
+            </a:r>
+          </a:p>
+        </p:txBody>
+      </p:sp>
+      <p:sp>
+        <p:nvSpPr>
+          <p:cNvPr id="4" name="Subtitle 3"/>
+          <p:cNvSpPr>
+            <a:spLocks noGrp="1"/>
+          </p:cNvSpPr>
+          <p:nvPr>
+            <p:ph type="subTitle" idx="1"/>
+          </p:nvPr>
+        </p:nvSpPr>
+        <p:spPr>
+          <a:xfrm>
+            <a:ext cx="11438874" cy="0"/>
+          </a:xfrm>
+        </p:spPr>
+        <p:txBody>
+          <a:bodyPr/>
+          <a:lstStyle/>
+          <a:p>
+            <a:r>
+              <a:t>WCGRRT: rig visit and daily reports   ·   08:30–10:00</a:t>
+            </a:r>
+          </a:p>
+        </p:txBody>
+      </p:sp>
+    </p:spTree>
+  </p:cSld>
+  <p:clrMapOvr>
+    <a:masterClrMapping/>
+  </p:clrMapOvr>
+</p:sld>
+</file>
+
+<file path=ppt/slides/slide6.xml><?xml version="1.0" encoding="utf-8"?>
 <p:sld xmlns:a="http://schemas.openxmlformats.org/drawingml/2006/main" xmlns:p="http://schemas.openxmlformats.org/presentationml/2006/main" xmlns:r="http://schemas.openxmlformats.org/officeDocument/2006/relationships">
   <p:cSld>
     <p:spTree>
@@ -39736,7 +40047,7 @@
 </p:sld>
 </file>
 
-<file path=ppt/slides/slide6.xml><?xml version="1.0" encoding="utf-8"?>
+<file path=ppt/slides/slide7.xml><?xml version="1.0" encoding="utf-8"?>
 <p:sld xmlns:a="http://schemas.openxmlformats.org/drawingml/2006/main" xmlns:p="http://schemas.openxmlformats.org/presentationml/2006/main" xmlns:r="http://schemas.openxmlformats.org/officeDocument/2006/relationships">
   <p:cSld>
     <p:spTree>
@@ -40060,7 +40371,7 @@
 </p:sld>
 </file>
 
-<file path=ppt/slides/slide7.xml><?xml version="1.0" encoding="utf-8"?>
+<file path=ppt/slides/slide8.xml><?xml version="1.0" encoding="utf-8"?>
 <p:sld xmlns:a="http://schemas.openxmlformats.org/drawingml/2006/main" xmlns:p="http://schemas.openxmlformats.org/presentationml/2006/main" xmlns:r="http://schemas.openxmlformats.org/officeDocument/2006/relationships">
   <p:cSld>
     <p:spTree>
@@ -40325,7 +40636,7 @@
 </p:sld>
 </file>
 
-<file path=ppt/slides/slide8.xml><?xml version="1.0" encoding="utf-8"?>
+<file path=ppt/slides/slide9.xml><?xml version="1.0" encoding="utf-8"?>
 <p:sld xmlns:a="http://schemas.openxmlformats.org/drawingml/2006/main" xmlns:p="http://schemas.openxmlformats.org/presentationml/2006/main" xmlns:r="http://schemas.openxmlformats.org/officeDocument/2006/relationships">
   <p:cSld>
     <p:spTree>
@@ -40382,247 +40693,6 @@
           <a:p>
             <a:r>
               <a:t>WCGRRT: the surface tests and posting   ·   10:15–12:00</a:t>
-            </a:r>
-          </a:p>
-        </p:txBody>
-      </p:sp>
-    </p:spTree>
-  </p:cSld>
-  <p:clrMapOvr>
-    <a:masterClrMapping/>
-  </p:clrMapOvr>
-</p:sld>
-</file>
-
-<file path=ppt/slides/slide9.xml><?xml version="1.0" encoding="utf-8"?>
-<p:sld xmlns:a="http://schemas.openxmlformats.org/drawingml/2006/main" xmlns:p="http://schemas.openxmlformats.org/presentationml/2006/main" xmlns:r="http://schemas.openxmlformats.org/officeDocument/2006/relationships">
-  <p:cSld>
-    <p:spTree>
-      <p:nvGrpSpPr>
-        <p:cNvPr id="1" name=""/>
-        <p:cNvGrpSpPr/>
-        <p:nvPr/>
-      </p:nvGrpSpPr>
-      <p:grpSpPr/>
-      <p:sp>
-        <p:nvSpPr>
-          <p:cNvPr id="3" name="Title 2"/>
-          <p:cNvSpPr>
-            <a:spLocks noGrp="1"/>
-          </p:cNvSpPr>
-          <p:nvPr>
-            <p:ph type="title"/>
-          </p:nvPr>
-        </p:nvSpPr>
-        <p:spPr>
-          <a:xfrm>
-            <a:ext cx="11411760" cy="0"/>
-          </a:xfrm>
-        </p:spPr>
-        <p:txBody>
-          <a:bodyPr/>
-          <a:lstStyle/>
-          <a:p>
-            <a:r>
-              <a:rPr sz="3000" b="1"/>
-              <a:t>Five surface tests, all native now</a:t>
-            </a:r>
-          </a:p>
-        </p:txBody>
-      </p:sp>
-      <p:sp>
-        <p:nvSpPr>
-          <p:cNvPr id="4" name="Text Placeholder 3"/>
-          <p:cNvSpPr>
-            <a:spLocks noGrp="1"/>
-          </p:cNvSpPr>
-          <p:nvPr>
-            <p:ph type="body" idx="13" sz="quarter"/>
-          </p:nvPr>
-        </p:nvSpPr>
-        <p:spPr>
-          <a:xfrm>
-            <a:ext cx="11411760" cy="0"/>
-          </a:xfrm>
-        </p:spPr>
-        <p:txBody>
-          <a:bodyPr/>
-          <a:lstStyle/>
-          <a:p>
-            <a:r>
-              <a:rPr sz="1300" b="1">
-                <a:solidFill>
-                  <a:srgbClr val="5A6472"/>
-                </a:solidFill>
-              </a:rPr>
-              <a:t>REV 165 and 166 — the embedded tools are gone</a:t>
-            </a:r>
-          </a:p>
-        </p:txBody>
-      </p:sp>
-      <p:sp>
-        <p:nvSpPr>
-          <p:cNvPr id="5" name="Text Placeholder 4"/>
-          <p:cNvSpPr>
-            <a:spLocks noGrp="1"/>
-          </p:cNvSpPr>
-          <p:nvPr>
-            <p:ph type="body" idx="14" sz="quarter"/>
-          </p:nvPr>
-        </p:nvSpPr>
-        <p:spPr>
-          <a:xfrm>
-            <a:ext cx="11411760" cy="0"/>
-          </a:xfrm>
-        </p:spPr>
-        <p:txBody>
-          <a:bodyPr wrap="square"/>
-          <a:lstStyle/>
-          <a:p>
-            <a:pPr>
-              <a:spcAft>
-                <a:spcPts val="600"/>
-              </a:spcAft>
-            </a:pPr>
-            <a:r>
-              <a:rPr sz="1400" b="1"/>
-              <a:t>BOP Function Test</a:t>
-            </a:r>
-          </a:p>
-          <a:p>
-            <a:pPr>
-              <a:spcAft>
-                <a:spcPts val="600"/>
-              </a:spcAft>
-            </a:pPr>
-            <a:r>
-              <a:rPr sz="1400" b="0"/>
-              <a:t>ILF rows, pod pressures, regulator checks.</a:t>
-            </a:r>
-          </a:p>
-          <a:p>
-            <a:pPr>
-              <a:spcAft>
-                <a:spcPts val="600"/>
-              </a:spcAft>
-            </a:pPr>
-            <a:r>
-              <a:rPr sz="1400" b="1"/>
-              <a:t>EDS Verification</a:t>
-            </a:r>
-          </a:p>
-          <a:p>
-            <a:pPr>
-              <a:spcAft>
-                <a:spcPts val="600"/>
-              </a:spcAft>
-            </a:pPr>
-            <a:r>
-              <a:rPr sz="1400" b="0"/>
-              <a:t>Your rig's own sequences, step by step, with actual times and remarks.</a:t>
-            </a:r>
-          </a:p>
-          <a:p>
-            <a:pPr>
-              <a:spcAft>
-                <a:spcPts val="600"/>
-              </a:spcAft>
-            </a:pPr>
-            <a:r>
-              <a:rPr sz="1400" b="1"/>
-              <a:t>Acoustic Function Test</a:t>
-            </a:r>
-          </a:p>
-          <a:p>
-            <a:pPr>
-              <a:spcAft>
-                <a:spcPts val="600"/>
-              </a:spcAft>
-            </a:pPr>
-            <a:r>
-              <a:rPr sz="1400" b="0"/>
-              <a:t>Rig-specific. Three rigs have no acoustic system and will say so.</a:t>
-            </a:r>
-          </a:p>
-          <a:p>
-            <a:pPr>
-              <a:spcAft>
-                <a:spcPts val="600"/>
-              </a:spcAft>
-            </a:pPr>
-            <a:r>
-              <a:rPr sz="1400" b="1"/>
-              <a:t>EHBS</a:t>
-            </a:r>
-          </a:p>
-          <a:p>
-            <a:pPr>
-              <a:spcAft>
-                <a:spcPts val="600"/>
-              </a:spcAft>
-            </a:pPr>
-            <a:r>
-              <a:rPr sz="1400" b="0"/>
-              <a:t>Three rig classes. DMAS gets a two-part test.</a:t>
-            </a:r>
-          </a:p>
-          <a:p>
-            <a:pPr>
-              <a:spcAft>
-                <a:spcPts val="600"/>
-              </a:spcAft>
-            </a:pPr>
-            <a:r>
-              <a:rPr sz="1400" b="1"/>
-              <a:t>Surface Drawdown</a:t>
-            </a:r>
-          </a:p>
-          <a:p>
-            <a:pPr>
-              <a:spcAft>
-                <a:spcPts val="600"/>
-              </a:spcAft>
-            </a:pPr>
-            <a:r>
-              <a:rPr sz="1400" b="0"/>
-              <a:t>Derived PASS/FAIL — see the next point.</a:t>
-            </a:r>
-          </a:p>
-          <a:p>
-            <a:pPr>
-              <a:spcAft>
-                <a:spcPts val="600"/>
-              </a:spcAft>
-            </a:pPr>
-            <a:r>
-              <a:rPr sz="1400" b="0"/>
-              <a:t/>
-            </a:r>
-          </a:p>
-          <a:p>
-            <a:pPr>
-              <a:spcAft>
-                <a:spcPts val="600"/>
-              </a:spcAft>
-            </a:pPr>
-            <a:r>
-              <a:rPr sz="1400" b="1">
-                <a:solidFill>
-                  <a:srgbClr val="E25303"/>
-                </a:solidFill>
-              </a:rPr>
-              <a:t>Until REV 165 these were embedded tools and nothing you typed was saved.</a:t>
-            </a:r>
-          </a:p>
-          <a:p>
-            <a:pPr>
-              <a:spcAft>
-                <a:spcPts val="600"/>
-              </a:spcAft>
-            </a:pPr>
-            <a:r>
-              <a:rPr sz="1400" b="0"/>
-              <a:t>It printed and it looked right. It never reached the report. That is fixed; it is also why this module exists.</a:t>
             </a:r>
           </a:p>
         </p:txBody>

</xml_diff>